<commit_message>
Balance team contributions and enlarge historical screen example
</commit_message>
<xml_diff>
--- a/submission/prezentaciya-finalnaya-2026-09-07-model-i-interfeys.pptx
+++ b/submission/prezentaciya-finalnaya-2026-09-07-model-i-interfeys.pptx
@@ -12277,6 +12277,54 @@
               <a:t>Отдельно оцениваем размер изменения и свежесть источника. Для пуша используем собственный строгий фильтр.</a:t>
             </a:r>
           </a:p>
+          <a:p xmlns:a="http://schemas.openxmlformats.org/drawingml/2006/main">
+            <a:pPr>
+              <a:buNone/>
+              <a:defRPr sz="1250">
+                <a:solidFill>
+                  <a:srgbClr val="4E5966"/>
+                </a:solidFill>
+                <a:latin typeface="Calibri"/>
+                <a:ea typeface="Calibri"/>
+                <a:cs typeface="Calibri"/>
+              </a:defRPr>
+            </a:pPr>
+            <a:r>
+              <a:rPr sz="1250">
+                <a:solidFill>
+                  <a:srgbClr val="4E5966"/>
+                </a:solidFill>
+                <a:latin typeface="Calibri"/>
+                <a:ea typeface="Calibri"/>
+                <a:cs typeface="Calibri"/>
+              </a:rPr>
+              <a:t/>
+            </a:r>
+          </a:p>
+          <a:p xmlns:a="http://schemas.openxmlformats.org/drawingml/2006/main">
+            <a:pPr>
+              <a:buNone/>
+              <a:defRPr sz="1250">
+                <a:solidFill>
+                  <a:srgbClr val="4E5966"/>
+                </a:solidFill>
+                <a:latin typeface="Calibri"/>
+                <a:ea typeface="Calibri"/>
+                <a:cs typeface="Calibri"/>
+              </a:defRPr>
+            </a:pPr>
+            <a:r>
+              <a:rPr sz="1250">
+                <a:solidFill>
+                  <a:srgbClr val="4E5966"/>
+                </a:solidFill>
+                <a:latin typeface="Calibri"/>
+                <a:ea typeface="Calibri"/>
+                <a:cs typeface="Calibri"/>
+              </a:rPr>
+              <a:t>Сообщение выбираем по самым важным подтверждённым сигналам из прошлого: изменению за неделю или редкому уровню курса.</a:t>
+            </a:r>
+          </a:p>
         </p:txBody>
       </p:sp>
       <p:sp>
@@ -12362,7 +12410,7 @@
                 <a:ea typeface="Cambria"/>
                 <a:cs typeface="Cambria"/>
               </a:rPr>
-              <a:t>Что видит клиент</a:t>
+              <a:t/>
             </a:r>
           </a:p>
         </p:txBody>
@@ -12420,7 +12468,7 @@
                 <a:ea typeface="Calibri"/>
                 <a:cs typeface="Calibri"/>
               </a:rPr>
-              <a:t>Сумма и сравнение с историей</a:t>
+              <a:t/>
             </a:r>
           </a:p>
         </p:txBody>
@@ -12614,7 +12662,7 @@
         <p:spPr>
           <a:xfrm xmlns:a="http://schemas.openxmlformats.org/drawingml/2006/main">
             <a:off x="640080" y="6309360"/>
-            <a:ext cx="10881360" cy="329184"/>
+            <a:ext cx="6537960" cy="329184"/>
           </a:xfrm>
           <a:prstGeom xmlns:a="http://schemas.openxmlformats.org/drawingml/2006/main" prst="rect">
             <a:avLst/>
@@ -13243,12 +13291,15 @@
         </p:nvPicPr>
         <p:blipFill>
           <a:blip xmlns:r="http://schemas.openxmlformats.org/officeDocument/2006/relationships" xmlns:a="http://schemas.openxmlformats.org/drawingml/2006/main" r:embed="rIdTemperatureClientExample"/>
-          <a:stretch xmlns:a="http://schemas.openxmlformats.org/drawingml/2006/main"/>
+          <a:srcRect xmlns:a="http://schemas.openxmlformats.org/drawingml/2006/main" l="5000" t="34000" r="5000" b="3000"/>
+          <a:stretch xmlns:a="http://schemas.openxmlformats.org/drawingml/2006/main">
+            <a:fillRect l="0" t="0" r="0" b="0"/>
+          </a:stretch>
         </p:blipFill>
         <p:spPr>
           <a:xfrm xmlns:a="http://schemas.openxmlformats.org/drawingml/2006/main">
-            <a:off x="8293692" y="1956816"/>
-            <a:ext cx="1974936" cy="4029266"/>
+            <a:off x="7763256" y="1344168"/>
+            <a:ext cx="3521488" cy="5029200"/>
           </a:xfrm>
           <a:prstGeom xmlns:a="http://schemas.openxmlformats.org/drawingml/2006/main" prst="rect">
             <a:avLst/>
@@ -19290,7 +19341,7 @@
         <p:spPr>
           <a:xfrm xmlns:a="http://schemas.openxmlformats.org/drawingml/2006/main">
             <a:off x="896112" y="1993392"/>
-            <a:ext cx="3008376" cy="1389888"/>
+            <a:ext cx="3008376" cy="1892808"/>
           </a:xfrm>
           <a:prstGeom xmlns:a="http://schemas.openxmlformats.org/drawingml/2006/main" prst="rect">
             <a:avLst/>
@@ -19316,7 +19367,87 @@
                 <a:ea typeface="Calibri"/>
                 <a:cs typeface="Calibri"/>
               </a:rPr>
-              <a:t>AI Product. Продуктовая постановка, клиентский путь, макеты, тексты, базовые индикаторы и комплект материалов.</a:t>
+              <a:t>AI Product. Продуктовая постановка, поиск и анализ продуктовых идей.</a:t>
+            </a:r>
+            <a:endParaRPr sz="1250"/>
+          </a:p>
+          <a:p xmlns:a="http://schemas.openxmlformats.org/drawingml/2006/main">
+            <a:pPr marL="0" indent="0">
+              <a:lnSpc>
+                <a:spcPts val="1700"/>
+              </a:lnSpc>
+              <a:buNone/>
+            </a:pPr>
+            <a:r>
+              <a:rPr sz="1250">
+                <a:solidFill>
+                  <a:srgbClr val="4E5966"/>
+                </a:solidFill>
+                <a:latin typeface="Calibri"/>
+                <a:ea typeface="Calibri"/>
+                <a:cs typeface="Calibri"/>
+              </a:rPr>
+              <a:t/>
+            </a:r>
+            <a:endParaRPr sz="1250"/>
+          </a:p>
+          <a:p xmlns:a="http://schemas.openxmlformats.org/drawingml/2006/main">
+            <a:pPr marL="0" indent="0">
+              <a:lnSpc>
+                <a:spcPts val="1700"/>
+              </a:lnSpc>
+              <a:buNone/>
+            </a:pPr>
+            <a:r>
+              <a:rPr sz="1250">
+                <a:solidFill>
+                  <a:srgbClr val="4E5966"/>
+                </a:solidFill>
+                <a:latin typeface="Calibri"/>
+                <a:ea typeface="Calibri"/>
+                <a:cs typeface="Calibri"/>
+              </a:rPr>
+              <a:t>Клиентский путь, макеты и тексты. MVP-модель и базовые индикаторы выгодного момента.</a:t>
+            </a:r>
+            <a:endParaRPr sz="1250"/>
+          </a:p>
+          <a:p xmlns:a="http://schemas.openxmlformats.org/drawingml/2006/main">
+            <a:pPr marL="0" indent="0">
+              <a:lnSpc>
+                <a:spcPts val="1700"/>
+              </a:lnSpc>
+              <a:buNone/>
+            </a:pPr>
+            <a:r>
+              <a:rPr sz="1250">
+                <a:solidFill>
+                  <a:srgbClr val="4E5966"/>
+                </a:solidFill>
+                <a:latin typeface="Calibri"/>
+                <a:ea typeface="Calibri"/>
+                <a:cs typeface="Calibri"/>
+              </a:rPr>
+              <a:t/>
+            </a:r>
+            <a:endParaRPr sz="1250"/>
+          </a:p>
+          <a:p xmlns:a="http://schemas.openxmlformats.org/drawingml/2006/main">
+            <a:pPr marL="0" indent="0">
+              <a:lnSpc>
+                <a:spcPts val="1700"/>
+              </a:lnSpc>
+              <a:buNone/>
+            </a:pPr>
+            <a:r>
+              <a:rPr sz="1250">
+                <a:solidFill>
+                  <a:srgbClr val="4E5966"/>
+                </a:solidFill>
+                <a:latin typeface="Calibri"/>
+                <a:ea typeface="Calibri"/>
+                <a:cs typeface="Calibri"/>
+              </a:rPr>
+              <a:t>Презентация проекта и подготовка комплекта материалов.</a:t>
             </a:r>
             <a:endParaRPr sz="1250"/>
           </a:p>
@@ -19414,7 +19545,7 @@
         <p:spPr>
           <a:xfrm xmlns:a="http://schemas.openxmlformats.org/drawingml/2006/main">
             <a:off x="4581144" y="1993392"/>
-            <a:ext cx="3008376" cy="1389888"/>
+            <a:ext cx="3008376" cy="1892808"/>
           </a:xfrm>
           <a:prstGeom xmlns:a="http://schemas.openxmlformats.org/drawingml/2006/main" prst="rect">
             <a:avLst/>
@@ -19440,7 +19571,47 @@
                 <a:ea typeface="Calibri"/>
                 <a:cs typeface="Calibri"/>
               </a:rPr>
-              <a:t>AI Engineer. Данные и признаки, независимая реализация version_b, модели и проверка расчётов.</a:t>
+              <a:t>AI Engineer. Данные и признаки, независимая реализация version_b.</a:t>
+            </a:r>
+            <a:endParaRPr sz="1250"/>
+          </a:p>
+          <a:p xmlns:a="http://schemas.openxmlformats.org/drawingml/2006/main">
+            <a:pPr marL="0" indent="0">
+              <a:lnSpc>
+                <a:spcPts val="1700"/>
+              </a:lnSpc>
+              <a:buNone/>
+            </a:pPr>
+            <a:r>
+              <a:rPr sz="1250">
+                <a:solidFill>
+                  <a:srgbClr val="4E5966"/>
+                </a:solidFill>
+                <a:latin typeface="Calibri"/>
+                <a:ea typeface="Calibri"/>
+                <a:cs typeface="Calibri"/>
+              </a:rPr>
+              <a:t/>
+            </a:r>
+            <a:endParaRPr sz="1250"/>
+          </a:p>
+          <a:p xmlns:a="http://schemas.openxmlformats.org/drawingml/2006/main">
+            <a:pPr marL="0" indent="0">
+              <a:lnSpc>
+                <a:spcPts val="1700"/>
+              </a:lnSpc>
+              <a:buNone/>
+            </a:pPr>
+            <a:r>
+              <a:rPr sz="1250">
+                <a:solidFill>
+                  <a:srgbClr val="4E5966"/>
+                </a:solidFill>
+                <a:latin typeface="Calibri"/>
+                <a:ea typeface="Calibri"/>
+                <a:cs typeface="Calibri"/>
+              </a:rPr>
+              <a:t>Обучение моделей, контроль утечек и проверка расчётов.</a:t>
             </a:r>
             <a:endParaRPr sz="1250"/>
           </a:p>
@@ -19604,7 +19775,7 @@
                 <a:ea typeface="Calibri"/>
                 <a:cs typeface="Calibri"/>
               </a:rPr>
-              <a:t>100+ вариантов моделей, признаков и правил отбора. Эксперименты по валютам и периодам, контроль утечек.</a:t>
+              <a:t>100+ вариантов моделей, признаков и правил отбора. Эксперименты по валютам и периодам.</a:t>
             </a:r>
             <a:endParaRPr sz="1250"/>
           </a:p>

</xml_diff>